<commit_message>
Backfill experiment registry and Exp7 fix plan
</commit_message>
<xml_diff>
--- a/PRD/weekly_pre_revised_experiment_registry_diag.pptx
+++ b/PRD/weekly_pre_revised_experiment_registry_diag.pptx
@@ -29,6 +29,9 @@
     <p:sldId id="277" r:id="rId28"/>
     <p:sldId id="278" r:id="rId29"/>
     <p:sldId id="279" r:id="rId30"/>
+    <p:sldId id="280" r:id="rId31"/>
+    <p:sldId id="281" r:id="rId32"/>
+    <p:sldId id="282" r:id="rId33"/>
   </p:sldIdLst>
   <p:sldSz cx="12191695" cy="6858000" type="screen4x3"/>
   <p:notesSz cx="6858000" cy="9144000"/>
@@ -9308,6 +9311,592 @@
             </a:pPr>
             <a:r>
               <a:t>先调通 Exp7-fix，再回到 D3/YouTube-VOS；YouTube-VOS/D3 必须用 SFT-48000 DiffuEraser 权重。</a:t>
+            </a:r>
+          </a:p>
+        </p:txBody>
+      </p:sp>
+    </p:spTree>
+  </p:cSld>
+  <p:clrMapOvr>
+    <a:masterClrMapping/>
+  </p:clrMapOvr>
+</p:sld>
+</file>
+
+<file path=ppt/slides/slide25.xml><?xml version="1.0" encoding="utf-8"?>
+<p:sld xmlns:a="http://schemas.openxmlformats.org/drawingml/2006/main" xmlns:p="http://schemas.openxmlformats.org/presentationml/2006/main" xmlns:r="http://schemas.openxmlformats.org/officeDocument/2006/relationships">
+  <p:cSld>
+    <p:spTree>
+      <p:nvGrpSpPr>
+        <p:cNvPr id="1" name=""/>
+        <p:cNvGrpSpPr/>
+        <p:nvPr/>
+      </p:nvGrpSpPr>
+      <p:grpSpPr/>
+      <p:sp>
+        <p:nvSpPr>
+          <p:cNvPr id="2" name="TextBox 1"/>
+          <p:cNvSpPr txBox="1"/>
+          <p:nvPr/>
+        </p:nvSpPr>
+        <p:spPr>
+          <a:xfrm>
+            <a:off x="502920" y="320040"/>
+            <a:ext cx="11201400" cy="502920"/>
+          </a:xfrm>
+          <a:prstGeom prst="rect">
+            <a:avLst/>
+          </a:prstGeom>
+          <a:noFill/>
+        </p:spPr>
+        <p:txBody>
+          <a:bodyPr wrap="none">
+            <a:spAutoFit/>
+          </a:bodyPr>
+          <a:lstStyle/>
+          <a:p>
+            <a:pPr>
+              <a:defRPr sz="2500" b="1">
+                <a:solidFill>
+                  <a:srgbClr val="141414"/>
+                </a:solidFill>
+                <a:latin typeface="Microsoft YaHei"/>
+              </a:defRPr>
+            </a:pPr>
+            <a:r>
+              <a:t>PAI audit 回填：实验文件夹和 dpo_diag 找回来了</a:t>
+            </a:r>
+          </a:p>
+        </p:txBody>
+      </p:sp>
+      <p:sp>
+        <p:nvSpPr>
+          <p:cNvPr id="3" name="TextBox 2"/>
+          <p:cNvSpPr txBox="1"/>
+          <p:nvPr/>
+        </p:nvSpPr>
+        <p:spPr>
+          <a:xfrm>
+            <a:off x="530352" y="841248"/>
+            <a:ext cx="11064240" cy="320040"/>
+          </a:xfrm>
+          <a:prstGeom prst="rect">
+            <a:avLst/>
+          </a:prstGeom>
+          <a:noFill/>
+        </p:spPr>
+        <p:txBody>
+          <a:bodyPr wrap="none">
+            <a:spAutoFit/>
+          </a:bodyPr>
+          <a:lstStyle/>
+          <a:p>
+            <a:pPr>
+              <a:defRPr sz="1200">
+                <a:solidFill>
+                  <a:srgbClr val="5A5A5A"/>
+                </a:solidFill>
+                <a:latin typeface="Microsoft YaHei"/>
+              </a:defRPr>
+            </a:pPr>
+            <a:r>
+              <a:t>不是重新解释实验，而是把旧结果按 registry 重新落账</a:t>
+            </a:r>
+          </a:p>
+        </p:txBody>
+      </p:sp>
+      <p:sp>
+        <p:nvSpPr>
+          <p:cNvPr id="4" name="TextBox 3"/>
+          <p:cNvSpPr txBox="1"/>
+          <p:nvPr/>
+        </p:nvSpPr>
+        <p:spPr>
+          <a:xfrm>
+            <a:off x="685800" y="1234440"/>
+            <a:ext cx="10972800" cy="5212080"/>
+          </a:xfrm>
+          <a:prstGeom prst="rect">
+            <a:avLst/>
+          </a:prstGeom>
+          <a:noFill/>
+        </p:spPr>
+        <p:txBody>
+          <a:bodyPr wrap="square">
+            <a:spAutoFit/>
+          </a:bodyPr>
+          <a:lstStyle/>
+          <a:p>
+            <a:pPr>
+              <a:spcAft>
+                <a:spcPts val="500"/>
+              </a:spcAft>
+              <a:defRPr sz="1500">
+                <a:latin typeface="Microsoft YaHei"/>
+              </a:defRPr>
+            </a:pPr>
+            <a:r>
+              <a:t>PAI audit CSV: 34,448 行；找到 exp5/exp7/exp8/exp9 的训练、qual、target_eval、dpo_diagnostics 路径。</a:t>
+            </a:r>
+          </a:p>
+          <a:p>
+            <a:pPr>
+              <a:spcAft>
+                <a:spcPts val="500"/>
+              </a:spcAft>
+              <a:defRPr sz="1500">
+                <a:latin typeface="Microsoft YaHei"/>
+              </a:defRPr>
+            </a:pPr>
+            <a:r>
+              <a:t>新增独立条目：Exp5 beta10 plain。它不是 New Exp5，而是“只把 beta 从 500 降到 10、仍然没有 winner guardrail”的失败诊断。</a:t>
+            </a:r>
+          </a:p>
+          <a:p>
+            <a:pPr>
+              <a:spcAft>
+                <a:spcPts val="500"/>
+              </a:spcAft>
+              <a:defRPr sz="1500">
+                <a:latin typeface="Microsoft YaHei"/>
+              </a:defRPr>
+            </a:pPr>
+            <a:r>
+              <a:t>Old Exp5 / beta10 plain / New Exp5 / New Exp6 现在拆开讲：collapse -&gt; beta 不够 -&gt; winner anchor 有改善 -&gt; no-comp 诊断。</a:t>
+            </a:r>
+          </a:p>
+          <a:p>
+            <a:pPr>
+              <a:spcAft>
+                <a:spcPts val="500"/>
+              </a:spcAft>
+              <a:defRPr sz="1500">
+                <a:latin typeface="Microsoft YaHei"/>
+              </a:defRPr>
+            </a:pPr>
+            <a:r>
+              <a:t>PAI 上找到的 dpo_diag 目前标记为 REMOTE_DIAG_PATH_FOUND；要做数值表需要把 CSV 拉回或在 PAI 上跑同一个汇总工具。</a:t>
+            </a:r>
+          </a:p>
+          <a:p>
+            <a:pPr>
+              <a:spcAft>
+                <a:spcPts val="500"/>
+              </a:spcAft>
+              <a:defRPr sz="1500">
+                <a:latin typeface="Microsoft YaHei"/>
+              </a:defRPr>
+            </a:pPr>
+            <a:r>
+              <a:t>结论口径：qualitative + metric + dpo_diag 三者一起判断；没有 dpo_diag 的实验不能写成 final success。</a:t>
+            </a:r>
+          </a:p>
+        </p:txBody>
+      </p:sp>
+    </p:spTree>
+  </p:cSld>
+  <p:clrMapOvr>
+    <a:masterClrMapping/>
+  </p:clrMapOvr>
+</p:sld>
+</file>
+
+<file path=ppt/slides/slide26.xml><?xml version="1.0" encoding="utf-8"?>
+<p:sld xmlns:a="http://schemas.openxmlformats.org/drawingml/2006/main" xmlns:p="http://schemas.openxmlformats.org/presentationml/2006/main" xmlns:r="http://schemas.openxmlformats.org/officeDocument/2006/relationships">
+  <p:cSld>
+    <p:spTree>
+      <p:nvGrpSpPr>
+        <p:cNvPr id="1" name=""/>
+        <p:cNvGrpSpPr/>
+        <p:nvPr/>
+      </p:nvGrpSpPr>
+      <p:grpSpPr/>
+      <p:sp>
+        <p:nvSpPr>
+          <p:cNvPr id="2" name="TextBox 1"/>
+          <p:cNvSpPr txBox="1"/>
+          <p:nvPr/>
+        </p:nvSpPr>
+        <p:spPr>
+          <a:xfrm>
+            <a:off x="502920" y="320040"/>
+            <a:ext cx="11201400" cy="502920"/>
+          </a:xfrm>
+          <a:prstGeom prst="rect">
+            <a:avLst/>
+          </a:prstGeom>
+          <a:noFill/>
+        </p:spPr>
+        <p:txBody>
+          <a:bodyPr wrap="none">
+            <a:spAutoFit/>
+          </a:bodyPr>
+          <a:lstStyle/>
+          <a:p>
+            <a:pPr>
+              <a:defRPr sz="2500" b="1">
+                <a:solidFill>
+                  <a:srgbClr val="141414"/>
+                </a:solidFill>
+                <a:latin typeface="Microsoft YaHei"/>
+              </a:defRPr>
+            </a:pPr>
+            <a:r>
+              <a:t>关键 DPO 实验的真实 loss</a:t>
+            </a:r>
+          </a:p>
+        </p:txBody>
+      </p:sp>
+      <p:sp>
+        <p:nvSpPr>
+          <p:cNvPr id="3" name="TextBox 2"/>
+          <p:cNvSpPr txBox="1"/>
+          <p:nvPr/>
+        </p:nvSpPr>
+        <p:spPr>
+          <a:xfrm>
+            <a:off x="530352" y="841248"/>
+            <a:ext cx="11064240" cy="320040"/>
+          </a:xfrm>
+          <a:prstGeom prst="rect">
+            <a:avLst/>
+          </a:prstGeom>
+          <a:noFill/>
+        </p:spPr>
+        <p:txBody>
+          <a:bodyPr wrap="none">
+            <a:spAutoFit/>
+          </a:bodyPr>
+          <a:lstStyle/>
+          <a:p>
+            <a:pPr>
+              <a:defRPr sz="1200">
+                <a:solidFill>
+                  <a:srgbClr val="5A5A5A"/>
+                </a:solidFill>
+                <a:latin typeface="Microsoft YaHei"/>
+              </a:defRPr>
+            </a:pPr>
+            <a:r>
+              <a:t>统一记号：win_gap = m_w - m_w_ref；lose_gap = m_l - m_l_ref</a:t>
+            </a:r>
+          </a:p>
+        </p:txBody>
+      </p:sp>
+      <p:sp>
+        <p:nvSpPr>
+          <p:cNvPr id="4" name="TextBox 3"/>
+          <p:cNvSpPr txBox="1"/>
+          <p:nvPr/>
+        </p:nvSpPr>
+        <p:spPr>
+          <a:xfrm>
+            <a:off x="502920" y="1234440"/>
+            <a:ext cx="11201400" cy="5029200"/>
+          </a:xfrm>
+          <a:prstGeom prst="rect">
+            <a:avLst/>
+          </a:prstGeom>
+          <a:noFill/>
+        </p:spPr>
+        <p:txBody>
+          <a:bodyPr wrap="square">
+            <a:spAutoFit/>
+          </a:bodyPr>
+          <a:lstStyle/>
+          <a:p>
+            <a:pPr>
+              <a:spcAft>
+                <a:spcPts val="300"/>
+              </a:spcAft>
+              <a:defRPr sz="1050" b="1">
+                <a:latin typeface="Microsoft YaHei"/>
+              </a:defRPr>
+            </a:pPr>
+            <a:r>
+              <a:t>实验                         真实 loss / 参数</a:t>
+            </a:r>
+          </a:p>
+          <a:p>
+            <a:pPr>
+              <a:spcAft>
+                <a:spcPts val="300"/>
+              </a:spcAft>
+              <a:defRPr sz="1050" b="0">
+                <a:latin typeface="Consolas"/>
+              </a:defRPr>
+            </a:pPr>
+            <a:r>
+              <a:t>Old Exp5 beta500 plain       L = -logσ{-0.5*500*(win_gap - lose_gap)}</a:t>
+            </a:r>
+          </a:p>
+          <a:p>
+            <a:pPr>
+              <a:spcAft>
+                <a:spcPts val="300"/>
+              </a:spcAft>
+              <a:defRPr sz="1050" b="0">
+                <a:latin typeface="Consolas"/>
+              </a:defRPr>
+            </a:pPr>
+            <a:r>
+              <a:t>Exp5 beta10 plain            L = -logσ{-0.5*10*(win_gap - lose_gap)}</a:t>
+            </a:r>
+          </a:p>
+          <a:p>
+            <a:pPr>
+              <a:spcAft>
+                <a:spcPts val="300"/>
+              </a:spcAft>
+              <a:defRPr sz="1050" b="0">
+                <a:latin typeface="Consolas"/>
+              </a:defRPr>
+            </a:pPr>
+            <a:r>
+              <a:t>New Exp5 D2 comp             L = -logσ{-0.5*10*(win_gap - 0.25*lose_gap)} + 0.05*m_w + ReLU(win_gap)</a:t>
+            </a:r>
+          </a:p>
+          <a:p>
+            <a:pPr>
+              <a:spcAft>
+                <a:spcPts val="300"/>
+              </a:spcAft>
+              <a:defRPr sz="1050" b="0">
+                <a:latin typeface="Consolas"/>
+              </a:defRPr>
+            </a:pPr>
+            <a:r>
+              <a:t>New Exp6 D2 no-comp          same as New Exp5；区别是 final_loser = raw_loser，不做 comp</a:t>
+            </a:r>
+          </a:p>
+          <a:p>
+            <a:pPr>
+              <a:spcAft>
+                <a:spcPts val="300"/>
+              </a:spcAft>
+              <a:defRPr sz="1050" b="0">
+                <a:latin typeface="Consolas"/>
+              </a:defRPr>
+            </a:pPr>
+            <a:r>
+              <a:t>Exp7 partial-mask task       same as New Exp5；区别是 train_mask_mode=partial, mask_from_manifest=true</a:t>
+            </a:r>
+          </a:p>
+          <a:p>
+            <a:pPr>
+              <a:spcAft>
+                <a:spcPts val="300"/>
+              </a:spcAft>
+              <a:defRPr sz="1050" b="0">
+                <a:latin typeface="Consolas"/>
+              </a:defRPr>
+            </a:pPr>
+            <a:r>
+              <a:t>Exp9 D3 comp/nocomp          same as New Exp5；数据源换成 YouTube-VOS/D3，Stage1 only</a:t>
+            </a:r>
+          </a:p>
+          <a:p>
+            <a:pPr>
+              <a:spcAft>
+                <a:spcPts val="300"/>
+              </a:spcAft>
+              <a:defRPr sz="1050" b="0">
+                <a:latin typeface="Consolas"/>
+              </a:defRPr>
+            </a:pPr>
+            <a:r>
+              <a:t>No-lose candidate            L = -logσ{-0.5*10*win_gap} + 0.05*m_w + ReLU(win_gap)</a:t>
+            </a:r>
+          </a:p>
+          <a:p>
+            <a:pPr>
+              <a:spcAft>
+                <a:spcPts val="300"/>
+              </a:spcAft>
+              <a:defRPr sz="1050" b="0">
+                <a:latin typeface="Consolas"/>
+              </a:defRPr>
+            </a:pPr>
+            <a:r>
+              <a:t>Exp8 region loss             只有代码确认 region-weighted MSE 后才算有效；目前作为 diagnostic 记录</a:t>
+            </a:r>
+          </a:p>
+        </p:txBody>
+      </p:sp>
+    </p:spTree>
+  </p:cSld>
+  <p:clrMapOvr>
+    <a:masterClrMapping/>
+  </p:clrMapOvr>
+</p:sld>
+</file>
+
+<file path=ppt/slides/slide27.xml><?xml version="1.0" encoding="utf-8"?>
+<p:sld xmlns:a="http://schemas.openxmlformats.org/drawingml/2006/main" xmlns:p="http://schemas.openxmlformats.org/presentationml/2006/main" xmlns:r="http://schemas.openxmlformats.org/officeDocument/2006/relationships">
+  <p:cSld>
+    <p:spTree>
+      <p:nvGrpSpPr>
+        <p:cNvPr id="1" name=""/>
+        <p:cNvGrpSpPr/>
+        <p:nvPr/>
+      </p:nvGrpSpPr>
+      <p:grpSpPr/>
+      <p:sp>
+        <p:nvSpPr>
+          <p:cNvPr id="2" name="TextBox 1"/>
+          <p:cNvSpPr txBox="1"/>
+          <p:nvPr/>
+        </p:nvSpPr>
+        <p:spPr>
+          <a:xfrm>
+            <a:off x="502920" y="320040"/>
+            <a:ext cx="11201400" cy="502920"/>
+          </a:xfrm>
+          <a:prstGeom prst="rect">
+            <a:avLst/>
+          </a:prstGeom>
+          <a:noFill/>
+        </p:spPr>
+        <p:txBody>
+          <a:bodyPr wrap="none">
+            <a:spAutoFit/>
+          </a:bodyPr>
+          <a:lstStyle/>
+          <a:p>
+            <a:pPr>
+              <a:defRPr sz="2500" b="1">
+                <a:solidFill>
+                  <a:srgbClr val="141414"/>
+                </a:solidFill>
+                <a:latin typeface="Microsoft YaHei"/>
+              </a:defRPr>
+            </a:pPr>
+            <a:r>
+              <a:t>下一步先修 Exp7：small mask + ProPainter prior</a:t>
+            </a:r>
+          </a:p>
+        </p:txBody>
+      </p:sp>
+      <p:sp>
+        <p:nvSpPr>
+          <p:cNvPr id="3" name="TextBox 2"/>
+          <p:cNvSpPr txBox="1"/>
+          <p:nvPr/>
+        </p:nvSpPr>
+        <p:spPr>
+          <a:xfrm>
+            <a:off x="530352" y="841248"/>
+            <a:ext cx="11064240" cy="320040"/>
+          </a:xfrm>
+          <a:prstGeom prst="rect">
+            <a:avLst/>
+          </a:prstGeom>
+          <a:noFill/>
+        </p:spPr>
+        <p:txBody>
+          <a:bodyPr wrap="none">
+            <a:spAutoFit/>
+          </a:bodyPr>
+          <a:lstStyle/>
+          <a:p>
+            <a:pPr>
+              <a:defRPr sz="1200">
+                <a:solidFill>
+                  <a:srgbClr val="5A5A5A"/>
+                </a:solidFill>
+                <a:latin typeface="Microsoft YaHei"/>
+              </a:defRPr>
+            </a:pPr>
+            <a:r>
+              <a:t>先把 VideoDPO partial-mask task 调通，再决定是否继续 D3</a:t>
+            </a:r>
+          </a:p>
+        </p:txBody>
+      </p:sp>
+      <p:sp>
+        <p:nvSpPr>
+          <p:cNvPr id="4" name="TextBox 3"/>
+          <p:cNvSpPr txBox="1"/>
+          <p:nvPr/>
+        </p:nvSpPr>
+        <p:spPr>
+          <a:xfrm>
+            <a:off x="685800" y="1234440"/>
+            <a:ext cx="10972800" cy="5212080"/>
+          </a:xfrm>
+          <a:prstGeom prst="rect">
+            <a:avLst/>
+          </a:prstGeom>
+          <a:noFill/>
+        </p:spPr>
+        <p:txBody>
+          <a:bodyPr wrap="square">
+            <a:spAutoFit/>
+          </a:bodyPr>
+          <a:lstStyle/>
+          <a:p>
+            <a:pPr>
+              <a:spcAft>
+                <a:spcPts val="500"/>
+              </a:spcAft>
+              <a:defRPr sz="1500">
+                <a:latin typeface="Microsoft YaHei"/>
+              </a:defRPr>
+            </a:pPr>
+            <a:r>
+              <a:t>当前 Exp7 问题：task 改成 partial-mask 后，DPO 和 DiffuEraser/SFT baseline 都看起来差，这不一定是 DPO 本身唯一问题。</a:t>
+            </a:r>
+          </a:p>
+          <a:p>
+            <a:pPr>
+              <a:spcAft>
+                <a:spcPts val="500"/>
+              </a:spcAft>
+              <a:defRPr sz="1500">
+                <a:latin typeface="Microsoft YaHei"/>
+              </a:defRPr>
+            </a:pPr>
+            <a:r>
+              <a:t>两个重点排查：旧 mask 可能太大；partial-mask inpainting 可能没有走 DiffuEraser 自带 ProPainter prior。</a:t>
+            </a:r>
+          </a:p>
+          <a:p>
+            <a:pPr>
+              <a:spcAft>
+                <a:spcPts val="500"/>
+              </a:spcAft>
+              <a:defRPr sz="1500">
+                <a:latin typeface="Microsoft YaHei"/>
+              </a:defRPr>
+            </a:pPr>
+            <a:r>
+              <a:t>新 Exp7-fix 数据：VideoDPO winner，mask area 15%-20%，K=4，prior_mode=propainter，保留 raw_loser 和 comp_loser。</a:t>
+            </a:r>
+          </a:p>
+          <a:p>
+            <a:pPr>
+              <a:spcAft>
+                <a:spcPts val="500"/>
+              </a:spcAft>
+              <a:defRPr sz="1500">
+                <a:latin typeface="Microsoft YaHei"/>
+              </a:defRPr>
+            </a:pPr>
+            <a:r>
+              <a:t>训练 gate：Stage1 only，1500 steps，ckpt every 500；不训练 Stage2，不跑 VBench。</a:t>
+            </a:r>
+          </a:p>
+          <a:p>
+            <a:pPr>
+              <a:spcAft>
+                <a:spcPts val="500"/>
+              </a:spcAft>
+              <a:defRPr sz="1500">
+                <a:latin typeface="Microsoft YaHei"/>
+              </a:defRPr>
+            </a:pPr>
+            <a:r>
+              <a:t>评估：四列视频 winner/GT + mask overlay + SFT-48000 DiffuEraser + 当前实验；指标用 inference/metrics.py wrapper。</a:t>
             </a:r>
           </a:p>
         </p:txBody>

</xml_diff>